<commit_message>
Präsentation: Folie 15 TCO je Kanal, Folie 16 PII erklärt
Co-Authored-By: Claude Opus 5.5 <noreply@anthropic.com>
Claude-Session: https://claude.ai/code/session_01Fiy9oHnQhARrzuwrUokJ12
</commit_message>
<xml_diff>
--- a/docs/praesentation/Verordnungcheck_Thomas_Valentin_Derk.pptx
+++ b/docs/praesentation/Verordnungcheck_Thomas_Valentin_Derk.pptx
@@ -1574,10 +1574,42 @@
           <a:p>
             <a:r>
               <a:rPr lang="en-US" dirty="0"/>
-              <a:t>VALENTIN · ca. 1,25 min (IHK: Tool-Vergleich, Fazit).
-Beim Eingabekanal war die Überraschung: Die KI kostet nur 70 bis 142 € im Jahr. Die Gesamtkosten liegen bei 823 bis 2.054 €, weil die Eingabezeit der Rezeption dominiert.
-Deshalb haben wir Valentins Formular übernommen: strukturiert, keine Extraktionsfehler, und die Patientendaten werden ersetzt, bevor das Modell sie sieht.
-Fazit Tool-Vergleich: n8n, gpt-4.1-mini, Supabase mit RAG, Formular plus Chat.</a:t>
+              <a:t>VALENTIN · ca. 1,25 min (IHK: Tool-Vergleich, Fazit).</a:t>
+            </a:r>
+            <a:endParaRPr lang="en-US" dirty="0"/>
+          </a:p>
+          <a:p>
+            <a:r>
+              <a:rPr lang="en-US" dirty="0"/>
+              <a:t>Rechts, woraus die Kosten bestehen: Die KI kostet je nach Kanal nur 70 bis 142 € im Jahr, die Plattform 520 €, für alle Kanäle gleich. Der größte Posten ist die Eingabezeit der Rezeption: 218 € beim Scan bis 1.454 € beim Abtippen im Chat.</a:t>
+            </a:r>
+            <a:endParaRPr lang="en-US" dirty="0"/>
+          </a:p>
+          <a:p>
+            <a:r>
+              <a:rPr lang="en-US" dirty="0"/>
+              <a:t>Deshalb steht in der Tabelle je Kanal ein eigener Betrag: von 823 € (Scan) bis 2.054 € (Chat).</a:t>
+            </a:r>
+            <a:endParaRPr lang="en-US" dirty="0"/>
+          </a:p>
+          <a:p>
+            <a:r>
+              <a:rPr lang="en-US" dirty="0"/>
+              <a:t>Wir haben bewusst nicht den günstigsten Kanal gewählt, sondern das Formular: keine Lesefehler, und die Patientendaten werden ersetzt, bevor das Modell sie sieht. Qualität und Datenschutz gehen vor rund 700 € im Jahr. Foto und Scan sind der nächste Schritt; eine Scan-Variante läuft als Prototyp, ist aber noch nicht getestet.</a:t>
+            </a:r>
+            <a:endParaRPr lang="en-US" dirty="0"/>
+          </a:p>
+          <a:p>
+            <a:r>
+              <a:rPr lang="en-US" dirty="0"/>
+              <a:t>Fazit Tool-Vergleich: n8n, gpt-4.1-mini, Supabase mit RAG, Formular plus Chat.</a:t>
+            </a:r>
+            <a:endParaRPr lang="en-US" dirty="0"/>
+          </a:p>
+          <a:p>
+            <a:r>
+              <a:rPr lang="en-US" dirty="0"/>
+              <a:t>Falls gefragt: Die Eingabezeiten sind Annahmen und werden im Pilot gemessen. Einmalige Einrichtung ist nicht enthalten.</a:t>
             </a:r>
             <a:endParaRPr lang="en-US" dirty="0"/>
           </a:p>
@@ -1679,7 +1711,7 @@
           </a:p>
           <a:p>
             <a:r>
-              <a:t>PII-Reduktion (Architekturhinweis): Läuft die Eingabe über den Chat, geht der Text zuerst durch das NER-Modell bert-base-multilingual-cased-ner-hrl plus Regeln. Bei der Formular-Eingabe geht es regelbasiert weiter, Feld für Feld. Im Cloud-Prototyp greifen im Chat heute nur die Regeln, das Modell läuft lokal – echte Daten gehören deshalb nur in das Formular.</a:t>
+              <a:t>PII-Reduktion, also Reduktion personenbezogener Daten (Architekturhinweis): Läuft die Eingabe über den Chat, geht der Text zuerst durch das NER-Modell bert-base-multilingual-cased-ner-hrl plus Regeln. Bei der Formular-Eingabe geht es regelbasiert weiter, Feld für Feld. Im Cloud-Prototyp greifen im Chat heute nur die Regeln, das Modell läuft lokal – echte Daten gehören deshalb nur in das Formular.</a:t>
             </a:r>
           </a:p>
         </p:txBody>
@@ -13455,7 +13487,7 @@
               <a:buNone/>
             </a:pPr>
             <a:r>
-              <a:rPr lang="en-US" sz="2800" b="1" dirty="0">
+              <a:rPr lang="en-US" sz="2400" b="1" dirty="0">
                 <a:solidFill>
                   <a:schemeClr val="tx2"/>
                 </a:solidFill>
@@ -13463,7 +13495,7 @@
                 <a:ea typeface="Cambria" pitchFamily="34" charset="-122"/>
                 <a:cs typeface="Cambria" pitchFamily="34" charset="-120"/>
               </a:rPr>
-              <a:t>Eingabekanal und Gesamtkosten (TCO)</a:t>
+              <a:t>Eingabekanal und Gesamtkosten (Total Cost of Ownership – TCO)</a:t>
             </a:r>
             <a:endParaRPr lang="en-US" sz="2800" dirty="0"/>
           </a:p>
@@ -13571,16 +13603,17 @@
         </p:nvGraphicFramePr>
         <p:xfrm>
           <a:off x="548640" y="1325880"/>
-          <a:ext cx="7863840" cy="914400"/>
+          <a:ext cx="7863840" cy="3154680"/>
         </p:xfrm>
         <a:graphic>
           <a:graphicData uri="http://schemas.openxmlformats.org/drawingml/2006/table">
             <a:tbl>
               <a:tblPr/>
               <a:tblGrid>
-                <a:gridCol w="2377440"/>
-                <a:gridCol w="1371600"/>
-                <a:gridCol w="4114800"/>
+                <a:gridCol w="2011680"/>
+                <a:gridCol w="1280160"/>
+                <a:gridCol w="3108960"/>
+                <a:gridCol w="1463040"/>
               </a:tblGrid>
               <a:tr h="411480">
                 <a:tc>
@@ -13787,8 +13820,76 @@
                     </a:solidFill>
                   </a:tcPr>
                 </a:tc>
+                <a:tc>
+                  <a:txBody>
+                    <a:bodyPr/>
+                    <a:lstStyle/>
+                    <a:p>
+                      <a:pPr indent="0" marL="0" algn="r">
+                        <a:buNone/>
+                      </a:pPr>
+                      <a:r>
+                        <a:rPr lang="en-US" sz="1300" b="1" dirty="0">
+                          <a:solidFill>
+                            <a:srgbClr val="FFFFFF"/>
+                          </a:solidFill>
+                          <a:latin typeface="Calibri" pitchFamily="34" charset="0"/>
+                          <a:ea typeface="Calibri" pitchFamily="34" charset="-122"/>
+                          <a:cs typeface="Calibri" pitchFamily="34" charset="-120"/>
+                        </a:rPr>
+                        <a:t>Kosten pro Jahr</a:t>
+                      </a:r>
+                      <a:endParaRPr lang="en-US" sz="1300" dirty="0">
+                        <a:latin typeface="Calibri" charset="0"/>
+                        <a:ea typeface="Calibri" charset="0"/>
+                        <a:cs typeface="Calibri" charset="0"/>
+                      </a:endParaRPr>
+                    </a:p>
+                  </a:txBody>
+                  <a:tcPr marL="64008" marR="64008" marT="64008" marB="64008" anchor="ctr">
+                    <a:lnL w="9525" cap="flat" cmpd="sng" algn="ctr">
+                      <a:solidFill>
+                        <a:srgbClr val="D5E0DE"/>
+                      </a:solidFill>
+                      <a:prstDash val="solid"/>
+                      <a:round/>
+                      <a:headEnd type="none" w="med" len="med"/>
+                      <a:tailEnd type="none" w="med" len="med"/>
+                    </a:lnL>
+                    <a:lnR w="9525" cap="flat" cmpd="sng" algn="ctr">
+                      <a:solidFill>
+                        <a:srgbClr val="D5E0DE"/>
+                      </a:solidFill>
+                      <a:prstDash val="solid"/>
+                      <a:round/>
+                      <a:headEnd type="none" w="med" len="med"/>
+                      <a:tailEnd type="none" w="med" len="med"/>
+                    </a:lnR>
+                    <a:lnT w="9525" cap="flat" cmpd="sng" algn="ctr">
+                      <a:solidFill>
+                        <a:srgbClr val="D5E0DE"/>
+                      </a:solidFill>
+                      <a:prstDash val="solid"/>
+                      <a:round/>
+                      <a:headEnd type="none" w="med" len="med"/>
+                      <a:tailEnd type="none" w="med" len="med"/>
+                    </a:lnT>
+                    <a:lnB w="9525" cap="flat" cmpd="sng" algn="ctr">
+                      <a:solidFill>
+                        <a:srgbClr val="D5E0DE"/>
+                      </a:solidFill>
+                      <a:prstDash val="solid"/>
+                      <a:round/>
+                      <a:headEnd type="none" w="med" len="med"/>
+                      <a:tailEnd type="none" w="med" len="med"/>
+                    </a:lnB>
+                    <a:solidFill>
+                      <a:srgbClr val="2A9D8F"/>
+                    </a:solidFill>
+                  </a:tcPr>
+                </a:tc>
               </a:tr>
-              <a:tr h="685800">
+              <a:tr h="548640">
                 <a:tc>
                   <a:txBody>
                     <a:bodyPr/>
@@ -13942,7 +14043,7 @@
                           <a:ea typeface="Calibri" pitchFamily="34" charset="-122"/>
                           <a:cs typeface="Calibri" pitchFamily="34" charset="-120"/>
                         </a:rPr>
-                        <a:t>Strukturiert, kein Extraktionsfehler, Patientendaten werden vor dem Modell ersetzt</a:t>
+                        <a:t>Strukturiert, keine Lesefehler; Patientendaten vor dem Modell ersetzt</a:t>
                       </a:r>
                       <a:endParaRPr lang="en-US" sz="1300" dirty="0">
                         <a:latin typeface="Calibri" charset="0"/>
@@ -13993,8 +14094,97 @@
                     </a:solidFill>
                   </a:tcPr>
                 </a:tc>
+                <a:tc>
+                  <a:txBody>
+                    <a:bodyPr/>
+                    <a:lstStyle/>
+                    <a:p>
+                      <a:pPr indent="0" marL="0" algn="r">
+                        <a:buNone/>
+                      </a:pPr>
+                      <a:r>
+                        <a:rPr lang="en-US" sz="1500" dirty="0" b="1">
+                          <a:solidFill>
+                            <a:srgbClr val="2A9D8F"/>
+                          </a:solidFill>
+                          <a:latin typeface="Calibri" pitchFamily="34" charset="0"/>
+                          <a:ea typeface="Calibri" pitchFamily="34" charset="-122"/>
+                          <a:cs typeface="Calibri" pitchFamily="34" charset="-120"/>
+                        </a:rPr>
+                        <a:t>1.680 €</a:t>
+                      </a:r>
+                      <a:endParaRPr lang="en-US" sz="1300" dirty="0">
+                        <a:latin typeface="Calibri" charset="0"/>
+                        <a:ea typeface="Calibri" charset="0"/>
+                        <a:cs typeface="Calibri" charset="0"/>
+                      </a:endParaRPr>
+                    </a:p>
+                    <a:p>
+                      <a:pPr indent="0" marL="0" algn="r">
+                        <a:buNone/>
+                      </a:pPr>
+                      <a:r>
+                        <a:rPr lang="en-US" sz="1000" dirty="0" b="0">
+                          <a:solidFill>
+                            <a:srgbClr val="1B2B30"/>
+                          </a:solidFill>
+                          <a:latin typeface="Calibri" pitchFamily="34" charset="0"/>
+                          <a:ea typeface="Calibri" pitchFamily="34" charset="-122"/>
+                          <a:cs typeface="Calibri" pitchFamily="34" charset="-120"/>
+                        </a:rPr>
+                        <a:t>Eingabe 1,5 min</a:t>
+                      </a:r>
+                      <a:endParaRPr lang="en-US" sz="1300" dirty="0">
+                        <a:latin typeface="Calibri" charset="0"/>
+                        <a:ea typeface="Calibri" charset="0"/>
+                        <a:cs typeface="Calibri" charset="0"/>
+                      </a:endParaRPr>
+                    </a:p>
+                  </a:txBody>
+                  <a:tcPr marL="64008" marR="64008" marT="64008" marB="64008" anchor="ctr">
+                    <a:lnL w="9525" cap="flat" cmpd="sng" algn="ctr">
+                      <a:solidFill>
+                        <a:srgbClr val="D5E0DE"/>
+                      </a:solidFill>
+                      <a:prstDash val="solid"/>
+                      <a:round/>
+                      <a:headEnd type="none" w="med" len="med"/>
+                      <a:tailEnd type="none" w="med" len="med"/>
+                    </a:lnL>
+                    <a:lnR w="9525" cap="flat" cmpd="sng" algn="ctr">
+                      <a:solidFill>
+                        <a:srgbClr val="D5E0DE"/>
+                      </a:solidFill>
+                      <a:prstDash val="solid"/>
+                      <a:round/>
+                      <a:headEnd type="none" w="med" len="med"/>
+                      <a:tailEnd type="none" w="med" len="med"/>
+                    </a:lnR>
+                    <a:lnT w="9525" cap="flat" cmpd="sng" algn="ctr">
+                      <a:solidFill>
+                        <a:srgbClr val="D5E0DE"/>
+                      </a:solidFill>
+                      <a:prstDash val="solid"/>
+                      <a:round/>
+                      <a:headEnd type="none" w="med" len="med"/>
+                      <a:tailEnd type="none" w="med" len="med"/>
+                    </a:lnT>
+                    <a:lnB w="9525" cap="flat" cmpd="sng" algn="ctr">
+                      <a:solidFill>
+                        <a:srgbClr val="D5E0DE"/>
+                      </a:solidFill>
+                      <a:prstDash val="solid"/>
+                      <a:round/>
+                      <a:headEnd type="none" w="med" len="med"/>
+                      <a:tailEnd type="none" w="med" len="med"/>
+                    </a:lnB>
+                    <a:solidFill>
+                      <a:srgbClr val="F5F9F8"/>
+                    </a:solidFill>
+                  </a:tcPr>
+                </a:tc>
               </a:tr>
-              <a:tr h="594360">
+              <a:tr h="548640">
                 <a:tc>
                   <a:txBody>
                     <a:bodyPr/>
@@ -14199,8 +14389,97 @@
                     </a:solidFill>
                   </a:tcPr>
                 </a:tc>
+                <a:tc>
+                  <a:txBody>
+                    <a:bodyPr/>
+                    <a:lstStyle/>
+                    <a:p>
+                      <a:pPr indent="0" marL="0" algn="r">
+                        <a:buNone/>
+                      </a:pPr>
+                      <a:r>
+                        <a:rPr lang="en-US" sz="1500" dirty="0" b="1">
+                          <a:solidFill>
+                            <a:srgbClr val="1B2B30"/>
+                          </a:solidFill>
+                          <a:latin typeface="Calibri" pitchFamily="34" charset="0"/>
+                          <a:ea typeface="Calibri" pitchFamily="34" charset="-122"/>
+                          <a:cs typeface="Calibri" pitchFamily="34" charset="-120"/>
+                        </a:rPr>
+                        <a:t>2.054 €</a:t>
+                      </a:r>
+                      <a:endParaRPr lang="en-US" sz="1300" dirty="0">
+                        <a:latin typeface="Calibri" charset="0"/>
+                        <a:ea typeface="Calibri" charset="0"/>
+                        <a:cs typeface="Calibri" charset="0"/>
+                      </a:endParaRPr>
+                    </a:p>
+                    <a:p>
+                      <a:pPr indent="0" marL="0" algn="r">
+                        <a:buNone/>
+                      </a:pPr>
+                      <a:r>
+                        <a:rPr lang="en-US" sz="1000" dirty="0" b="0">
+                          <a:solidFill>
+                            <a:srgbClr val="1B2B30"/>
+                          </a:solidFill>
+                          <a:latin typeface="Calibri" pitchFamily="34" charset="0"/>
+                          <a:ea typeface="Calibri" pitchFamily="34" charset="-122"/>
+                          <a:cs typeface="Calibri" pitchFamily="34" charset="-120"/>
+                        </a:rPr>
+                        <a:t>Eingabe 2 min</a:t>
+                      </a:r>
+                      <a:endParaRPr lang="en-US" sz="1300" dirty="0">
+                        <a:latin typeface="Calibri" charset="0"/>
+                        <a:ea typeface="Calibri" charset="0"/>
+                        <a:cs typeface="Calibri" charset="0"/>
+                      </a:endParaRPr>
+                    </a:p>
+                  </a:txBody>
+                  <a:tcPr marL="64008" marR="64008" marT="64008" marB="64008" anchor="ctr">
+                    <a:lnL w="9525" cap="flat" cmpd="sng" algn="ctr">
+                      <a:solidFill>
+                        <a:srgbClr val="D5E0DE"/>
+                      </a:solidFill>
+                      <a:prstDash val="solid"/>
+                      <a:round/>
+                      <a:headEnd type="none" w="med" len="med"/>
+                      <a:tailEnd type="none" w="med" len="med"/>
+                    </a:lnL>
+                    <a:lnR w="9525" cap="flat" cmpd="sng" algn="ctr">
+                      <a:solidFill>
+                        <a:srgbClr val="D5E0DE"/>
+                      </a:solidFill>
+                      <a:prstDash val="solid"/>
+                      <a:round/>
+                      <a:headEnd type="none" w="med" len="med"/>
+                      <a:tailEnd type="none" w="med" len="med"/>
+                    </a:lnR>
+                    <a:lnT w="9525" cap="flat" cmpd="sng" algn="ctr">
+                      <a:solidFill>
+                        <a:srgbClr val="D5E0DE"/>
+                      </a:solidFill>
+                      <a:prstDash val="solid"/>
+                      <a:round/>
+                      <a:headEnd type="none" w="med" len="med"/>
+                      <a:tailEnd type="none" w="med" len="med"/>
+                    </a:lnT>
+                    <a:lnB w="9525" cap="flat" cmpd="sng" algn="ctr">
+                      <a:solidFill>
+                        <a:srgbClr val="D5E0DE"/>
+                      </a:solidFill>
+                      <a:prstDash val="solid"/>
+                      <a:round/>
+                      <a:headEnd type="none" w="med" len="med"/>
+                      <a:tailEnd type="none" w="med" len="med"/>
+                    </a:lnB>
+                    <a:solidFill>
+                      <a:srgbClr val="FFFFFF"/>
+                    </a:solidFill>
+                  </a:tcPr>
+                </a:tc>
               </a:tr>
-              <a:tr h="594360">
+              <a:tr h="548640">
                 <a:tc>
                   <a:txBody>
                     <a:bodyPr/>
@@ -14286,7 +14565,7 @@
                           <a:ea typeface="Calibri" pitchFamily="34" charset="-122"/>
                           <a:cs typeface="Calibri" pitchFamily="34" charset="-120"/>
                         </a:rPr>
-                        <a:t>nur bei Puffer</a:t>
+                        <a:t>Prototyp, noch nicht getestet</a:t>
                       </a:r>
                       <a:endParaRPr lang="en-US" sz="1300" dirty="0">
                         <a:latin typeface="Calibri" charset="0"/>
@@ -14354,7 +14633,7 @@
                           <a:ea typeface="Calibri" pitchFamily="34" charset="-122"/>
                           <a:cs typeface="Calibri" pitchFamily="34" charset="-120"/>
                         </a:rPr>
-                        <a:t>Bequem, aber Lesefehler; Brücke bis zur E-Verordnung</a:t>
+                        <a:t>Schnellste Eingabe, aber Lesefehler möglich</a:t>
                       </a:r>
                       <a:endParaRPr lang="en-US" sz="1300" dirty="0">
                         <a:latin typeface="Calibri" charset="0"/>
@@ -14405,8 +14684,97 @@
                     </a:solidFill>
                   </a:tcPr>
                 </a:tc>
+                <a:tc>
+                  <a:txBody>
+                    <a:bodyPr/>
+                    <a:lstStyle/>
+                    <a:p>
+                      <a:pPr indent="0" marL="0" algn="r">
+                        <a:buNone/>
+                      </a:pPr>
+                      <a:r>
+                        <a:rPr lang="en-US" sz="1500" dirty="0" b="1">
+                          <a:solidFill>
+                            <a:srgbClr val="1B2B30"/>
+                          </a:solidFill>
+                          <a:latin typeface="Calibri" pitchFamily="34" charset="0"/>
+                          <a:ea typeface="Calibri" pitchFamily="34" charset="-122"/>
+                          <a:cs typeface="Calibri" pitchFamily="34" charset="-120"/>
+                        </a:rPr>
+                        <a:t>983 €</a:t>
+                      </a:r>
+                      <a:endParaRPr lang="en-US" sz="1300" dirty="0">
+                        <a:latin typeface="Calibri" charset="0"/>
+                        <a:ea typeface="Calibri" charset="0"/>
+                        <a:cs typeface="Calibri" charset="0"/>
+                      </a:endParaRPr>
+                    </a:p>
+                    <a:p>
+                      <a:pPr indent="0" marL="0" algn="r">
+                        <a:buNone/>
+                      </a:pPr>
+                      <a:r>
+                        <a:rPr lang="en-US" sz="1000" dirty="0" b="0">
+                          <a:solidFill>
+                            <a:srgbClr val="1B2B30"/>
+                          </a:solidFill>
+                          <a:latin typeface="Calibri" pitchFamily="34" charset="0"/>
+                          <a:ea typeface="Calibri" pitchFamily="34" charset="-122"/>
+                          <a:cs typeface="Calibri" pitchFamily="34" charset="-120"/>
+                        </a:rPr>
+                        <a:t>Eingabe 0,5 min</a:t>
+                      </a:r>
+                      <a:endParaRPr lang="en-US" sz="1300" dirty="0">
+                        <a:latin typeface="Calibri" charset="0"/>
+                        <a:ea typeface="Calibri" charset="0"/>
+                        <a:cs typeface="Calibri" charset="0"/>
+                      </a:endParaRPr>
+                    </a:p>
+                  </a:txBody>
+                  <a:tcPr marL="64008" marR="64008" marT="64008" marB="64008" anchor="ctr">
+                    <a:lnL w="9525" cap="flat" cmpd="sng" algn="ctr">
+                      <a:solidFill>
+                        <a:srgbClr val="D5E0DE"/>
+                      </a:solidFill>
+                      <a:prstDash val="solid"/>
+                      <a:round/>
+                      <a:headEnd type="none" w="med" len="med"/>
+                      <a:tailEnd type="none" w="med" len="med"/>
+                    </a:lnL>
+                    <a:lnR w="9525" cap="flat" cmpd="sng" algn="ctr">
+                      <a:solidFill>
+                        <a:srgbClr val="D5E0DE"/>
+                      </a:solidFill>
+                      <a:prstDash val="solid"/>
+                      <a:round/>
+                      <a:headEnd type="none" w="med" len="med"/>
+                      <a:tailEnd type="none" w="med" len="med"/>
+                    </a:lnR>
+                    <a:lnT w="9525" cap="flat" cmpd="sng" algn="ctr">
+                      <a:solidFill>
+                        <a:srgbClr val="D5E0DE"/>
+                      </a:solidFill>
+                      <a:prstDash val="solid"/>
+                      <a:round/>
+                      <a:headEnd type="none" w="med" len="med"/>
+                      <a:tailEnd type="none" w="med" len="med"/>
+                    </a:lnT>
+                    <a:lnB w="9525" cap="flat" cmpd="sng" algn="ctr">
+                      <a:solidFill>
+                        <a:srgbClr val="D5E0DE"/>
+                      </a:solidFill>
+                      <a:prstDash val="solid"/>
+                      <a:round/>
+                      <a:headEnd type="none" w="med" len="med"/>
+                      <a:tailEnd type="none" w="med" len="med"/>
+                    </a:lnB>
+                    <a:solidFill>
+                      <a:srgbClr val="F5F9F8"/>
+                    </a:solidFill>
+                  </a:tcPr>
+                </a:tc>
               </a:tr>
-              <a:tr h="594360">
+              <a:tr h="548640">
                 <a:tc>
                   <a:txBody>
                     <a:bodyPr/>
@@ -14560,7 +14928,7 @@
                           <a:ea typeface="Calibri" pitchFamily="34" charset="-122"/>
                           <a:cs typeface="Calibri" pitchFamily="34" charset="-120"/>
                         </a:rPr>
-                        <a:t>Mehr Schritte oder unsicherer Kanal für Gesundheitsdaten</a:t>
+                        <a:t>Scan nur mit Scanner am Empfang; Messenger: Gesundheitsdaten bei Meta</a:t>
                       </a:r>
                       <a:endParaRPr lang="en-US" sz="1300" dirty="0">
                         <a:latin typeface="Calibri" charset="0"/>
@@ -14611,8 +14979,97 @@
                     </a:solidFill>
                   </a:tcPr>
                 </a:tc>
+                <a:tc>
+                  <a:txBody>
+                    <a:bodyPr/>
+                    <a:lstStyle/>
+                    <a:p>
+                      <a:pPr indent="0" marL="0" algn="r">
+                        <a:buNone/>
+                      </a:pPr>
+                      <a:r>
+                        <a:rPr lang="en-US" sz="1500" dirty="0" b="1">
+                          <a:solidFill>
+                            <a:srgbClr val="1B2B30"/>
+                          </a:solidFill>
+                          <a:latin typeface="Calibri" pitchFamily="34" charset="0"/>
+                          <a:ea typeface="Calibri" pitchFamily="34" charset="-122"/>
+                          <a:cs typeface="Calibri" pitchFamily="34" charset="-120"/>
+                        </a:rPr>
+                        <a:t>823 €</a:t>
+                      </a:r>
+                      <a:endParaRPr lang="en-US" sz="1300" dirty="0">
+                        <a:latin typeface="Calibri" charset="0"/>
+                        <a:ea typeface="Calibri" charset="0"/>
+                        <a:cs typeface="Calibri" charset="0"/>
+                      </a:endParaRPr>
+                    </a:p>
+                    <a:p>
+                      <a:pPr indent="0" marL="0" algn="r">
+                        <a:buNone/>
+                      </a:pPr>
+                      <a:r>
+                        <a:rPr lang="en-US" sz="1000" dirty="0" b="0">
+                          <a:solidFill>
+                            <a:srgbClr val="1B2B30"/>
+                          </a:solidFill>
+                          <a:latin typeface="Calibri" pitchFamily="34" charset="0"/>
+                          <a:ea typeface="Calibri" pitchFamily="34" charset="-122"/>
+                          <a:cs typeface="Calibri" pitchFamily="34" charset="-120"/>
+                        </a:rPr>
+                        <a:t>Scan, Eingabe 0,3 min</a:t>
+                      </a:r>
+                      <a:endParaRPr lang="en-US" sz="1300" dirty="0">
+                        <a:latin typeface="Calibri" charset="0"/>
+                        <a:ea typeface="Calibri" charset="0"/>
+                        <a:cs typeface="Calibri" charset="0"/>
+                      </a:endParaRPr>
+                    </a:p>
+                  </a:txBody>
+                  <a:tcPr marL="64008" marR="64008" marT="64008" marB="64008" anchor="ctr">
+                    <a:lnL w="9525" cap="flat" cmpd="sng" algn="ctr">
+                      <a:solidFill>
+                        <a:srgbClr val="D5E0DE"/>
+                      </a:solidFill>
+                      <a:prstDash val="solid"/>
+                      <a:round/>
+                      <a:headEnd type="none" w="med" len="med"/>
+                      <a:tailEnd type="none" w="med" len="med"/>
+                    </a:lnL>
+                    <a:lnR w="9525" cap="flat" cmpd="sng" algn="ctr">
+                      <a:solidFill>
+                        <a:srgbClr val="D5E0DE"/>
+                      </a:solidFill>
+                      <a:prstDash val="solid"/>
+                      <a:round/>
+                      <a:headEnd type="none" w="med" len="med"/>
+                      <a:tailEnd type="none" w="med" len="med"/>
+                    </a:lnR>
+                    <a:lnT w="9525" cap="flat" cmpd="sng" algn="ctr">
+                      <a:solidFill>
+                        <a:srgbClr val="D5E0DE"/>
+                      </a:solidFill>
+                      <a:prstDash val="solid"/>
+                      <a:round/>
+                      <a:headEnd type="none" w="med" len="med"/>
+                      <a:tailEnd type="none" w="med" len="med"/>
+                    </a:lnT>
+                    <a:lnB w="9525" cap="flat" cmpd="sng" algn="ctr">
+                      <a:solidFill>
+                        <a:srgbClr val="D5E0DE"/>
+                      </a:solidFill>
+                      <a:prstDash val="solid"/>
+                      <a:round/>
+                      <a:headEnd type="none" w="med" len="med"/>
+                      <a:tailEnd type="none" w="med" len="med"/>
+                    </a:lnB>
+                    <a:solidFill>
+                      <a:srgbClr val="FFFFFF"/>
+                    </a:solidFill>
+                  </a:tcPr>
+                </a:tc>
               </a:tr>
-              <a:tr h="822960">
+              <a:tr h="548640">
                 <a:tc>
                   <a:txBody>
                     <a:bodyPr/>
@@ -14630,7 +15087,28 @@
                           <a:ea typeface="Calibri" pitchFamily="34" charset="-122"/>
                           <a:cs typeface="Calibri" pitchFamily="34" charset="-120"/>
                         </a:rPr>
-                        <a:t>Praxissoftware / E-Verordnung</a:t>
+                        <a:t>Praxissoftware /</a:t>
+                      </a:r>
+                      <a:br>
+                        <a:rPr lang="en-US" sz="1300" b="1" dirty="0">
+                          <a:solidFill>
+                            <a:srgbClr val="1B2B30"/>
+                          </a:solidFill>
+                          <a:latin typeface="Calibri" pitchFamily="34" charset="0"/>
+                          <a:ea typeface="Calibri" pitchFamily="34" charset="-122"/>
+                          <a:cs typeface="Calibri" pitchFamily="34" charset="-120"/>
+                        </a:rPr>
+                      </a:br>
+                      <a:r>
+                        <a:rPr lang="en-US" sz="1300" b="1" dirty="0">
+                          <a:solidFill>
+                            <a:srgbClr val="1B2B30"/>
+                          </a:solidFill>
+                          <a:latin typeface="Calibri" pitchFamily="34" charset="0"/>
+                          <a:ea typeface="Calibri" pitchFamily="34" charset="-122"/>
+                          <a:cs typeface="Calibri" pitchFamily="34" charset="-120"/>
+                        </a:rPr>
+                        <a:t>E-Verordnung</a:t>
                       </a:r>
                       <a:endParaRPr lang="en-US" sz="1300" dirty="0">
                         <a:latin typeface="Calibri" charset="0"/>
@@ -14766,7 +15244,96 @@
                           <a:ea typeface="Calibri" pitchFamily="34" charset="-122"/>
                           <a:cs typeface="Calibri" pitchFamily="34" charset="-120"/>
                         </a:rPr>
-                        <a:t>Beste Lösung, aber Schnittstelle nötig; E-Verordnung über die TI macht Texterkennung zur Übergangslösung</a:t>
+                        <a:t>Beste Lösung, keine Eingabe; Schnittstelle zur Praxissoftware nötig</a:t>
+                      </a:r>
+                      <a:endParaRPr lang="en-US" sz="1300" dirty="0">
+                        <a:latin typeface="Calibri" charset="0"/>
+                        <a:ea typeface="Calibri" charset="0"/>
+                        <a:cs typeface="Calibri" charset="0"/>
+                      </a:endParaRPr>
+                    </a:p>
+                  </a:txBody>
+                  <a:tcPr marL="64008" marR="64008" marT="64008" marB="64008" anchor="ctr">
+                    <a:lnL w="9525" cap="flat" cmpd="sng" algn="ctr">
+                      <a:solidFill>
+                        <a:srgbClr val="D5E0DE"/>
+                      </a:solidFill>
+                      <a:prstDash val="solid"/>
+                      <a:round/>
+                      <a:headEnd type="none" w="med" len="med"/>
+                      <a:tailEnd type="none" w="med" len="med"/>
+                    </a:lnL>
+                    <a:lnR w="9525" cap="flat" cmpd="sng" algn="ctr">
+                      <a:solidFill>
+                        <a:srgbClr val="D5E0DE"/>
+                      </a:solidFill>
+                      <a:prstDash val="solid"/>
+                      <a:round/>
+                      <a:headEnd type="none" w="med" len="med"/>
+                      <a:tailEnd type="none" w="med" len="med"/>
+                    </a:lnR>
+                    <a:lnT w="9525" cap="flat" cmpd="sng" algn="ctr">
+                      <a:solidFill>
+                        <a:srgbClr val="D5E0DE"/>
+                      </a:solidFill>
+                      <a:prstDash val="solid"/>
+                      <a:round/>
+                      <a:headEnd type="none" w="med" len="med"/>
+                      <a:tailEnd type="none" w="med" len="med"/>
+                    </a:lnT>
+                    <a:lnB w="9525" cap="flat" cmpd="sng" algn="ctr">
+                      <a:solidFill>
+                        <a:srgbClr val="D5E0DE"/>
+                      </a:solidFill>
+                      <a:prstDash val="solid"/>
+                      <a:round/>
+                      <a:headEnd type="none" w="med" len="med"/>
+                      <a:tailEnd type="none" w="med" len="med"/>
+                    </a:lnB>
+                    <a:solidFill>
+                      <a:srgbClr val="F5F9F8"/>
+                    </a:solidFill>
+                  </a:tcPr>
+                </a:tc>
+                <a:tc>
+                  <a:txBody>
+                    <a:bodyPr/>
+                    <a:lstStyle/>
+                    <a:p>
+                      <a:pPr indent="0" marL="0" algn="r">
+                        <a:buNone/>
+                      </a:pPr>
+                      <a:r>
+                        <a:rPr lang="en-US" sz="1500" dirty="0" b="1">
+                          <a:solidFill>
+                            <a:srgbClr val="1B2B30"/>
+                          </a:solidFill>
+                          <a:latin typeface="Calibri" pitchFamily="34" charset="0"/>
+                          <a:ea typeface="Calibri" pitchFamily="34" charset="-122"/>
+                          <a:cs typeface="Calibri" pitchFamily="34" charset="-120"/>
+                        </a:rPr>
+                        <a:t>offen</a:t>
+                      </a:r>
+                      <a:endParaRPr lang="en-US" sz="1300" dirty="0">
+                        <a:latin typeface="Calibri" charset="0"/>
+                        <a:ea typeface="Calibri" charset="0"/>
+                        <a:cs typeface="Calibri" charset="0"/>
+                      </a:endParaRPr>
+                    </a:p>
+                    <a:p>
+                      <a:pPr indent="0" marL="0" algn="r">
+                        <a:buNone/>
+                      </a:pPr>
+                      <a:r>
+                        <a:rPr lang="en-US" sz="1000" dirty="0" b="0">
+                          <a:solidFill>
+                            <a:srgbClr val="1B2B30"/>
+                          </a:solidFill>
+                          <a:latin typeface="Calibri" pitchFamily="34" charset="0"/>
+                          <a:ea typeface="Calibri" pitchFamily="34" charset="-122"/>
+                          <a:cs typeface="Calibri" pitchFamily="34" charset="-120"/>
+                        </a:rPr>
+                        <a:t>Schnittstelle</a:t>
                       </a:r>
                       <a:endParaRPr lang="en-US" sz="1300" dirty="0">
                         <a:latin typeface="Calibri" charset="0"/>
@@ -14881,7 +15448,7 @@
                 <a:ea typeface="Cambria" pitchFamily="34" charset="-122"/>
                 <a:cs typeface="Cambria" pitchFamily="34" charset="-120"/>
               </a:rPr>
-              <a:t>Ergebnis TCO-Vergleich</a:t>
+              <a:t>Woraus die Kosten bestehen</a:t>
             </a:r>
             <a:endParaRPr lang="en-US" sz="1600" dirty="0"/>
           </a:p>
@@ -14917,7 +15484,7 @@
                   <a:schemeClr val="bg2"/>
                 </a:solidFill>
               </a:rPr>
-              <a:t>KI-Kosten</a:t>
+              <a:t>KI-Kosten, je nach Kanal</a:t>
             </a:r>
             <a:endParaRPr lang="en-US" sz="1200" dirty="0"/>
           </a:p>
@@ -14992,7 +15559,7 @@
                   <a:schemeClr val="bg2"/>
                 </a:solidFill>
               </a:rPr>
-              <a:t>Gesamtkosten je Kanal</a:t>
+              <a:t>Plattform (n8n, Supabase), für alle gleich</a:t>
             </a:r>
             <a:endParaRPr lang="en-US" sz="1200" dirty="0"/>
           </a:p>
@@ -15031,7 +15598,7 @@
                 <a:ea typeface="Cambria" pitchFamily="34" charset="-122"/>
                 <a:cs typeface="Cambria" pitchFamily="34" charset="-120"/>
               </a:rPr>
-              <a:t>823–2.054 € / Jahr</a:t>
+              <a:t>520 € / Jahr</a:t>
             </a:r>
             <a:endParaRPr lang="en-US" sz="2400" dirty="0"/>
           </a:p>
@@ -15039,14 +15606,89 @@
       </p:sp>
       <p:sp>
         <p:nvSpPr>
+          <p:cNvPr id="13" name="Text 9"/>
+          <p:cNvSpPr txBox="1"/>
+          <p:nvPr/>
+        </p:nvSpPr>
+        <p:spPr>
+          <a:xfrm>
+            <a:off x="8823960" y="3703320"/>
+            <a:ext cx="2606040" cy="274320"/>
+          </a:xfrm>
+          <a:prstGeom prst="rect">
+            <a:avLst/>
+          </a:prstGeom>
+          <a:noFill/>
+          <a:ln/>
+        </p:spPr>
+        <p:txBody>
+          <a:bodyPr wrap="square" lIns="0" tIns="0" rIns="0" bIns="0" rtlCol="0" anchor="t"/>
+          <a:lstStyle/>
+          <a:p>
+            <a:pPr indent="0" marL="0">
+              <a:buNone/>
+            </a:pPr>
+            <a:r>
+              <a:rPr lang="en-US" sz="1200" dirty="0">
+                <a:solidFill>
+                  <a:schemeClr val="bg2"/>
+                </a:solidFill>
+              </a:rPr>
+              <a:t>Eingabezeit der Rezeption</a:t>
+            </a:r>
+            <a:endParaRPr lang="en-US" sz="1200" dirty="0"/>
+          </a:p>
+        </p:txBody>
+      </p:sp>
+      <p:sp>
+        <p:nvSpPr>
+          <p:cNvPr id="14" name="Text 10"/>
+          <p:cNvSpPr txBox="1"/>
+          <p:nvPr/>
+        </p:nvSpPr>
+        <p:spPr>
+          <a:xfrm>
+            <a:off x="8823960" y="3959352"/>
+            <a:ext cx="2606040" cy="502920"/>
+          </a:xfrm>
+          <a:prstGeom prst="rect">
+            <a:avLst/>
+          </a:prstGeom>
+          <a:noFill/>
+          <a:ln/>
+        </p:spPr>
+        <p:txBody>
+          <a:bodyPr wrap="square" lIns="0" tIns="0" rIns="0" bIns="0" rtlCol="0" anchor="t"/>
+          <a:lstStyle/>
+          <a:p>
+            <a:pPr indent="0" marL="0">
+              <a:buNone/>
+            </a:pPr>
+            <a:r>
+              <a:rPr lang="en-US" sz="2400" b="1" dirty="0">
+                <a:solidFill>
+                  <a:srgbClr val="E76F51"/>
+                </a:solidFill>
+                <a:latin typeface="Cambria" pitchFamily="34" charset="0"/>
+                <a:ea typeface="Cambria" pitchFamily="34" charset="-122"/>
+                <a:cs typeface="Cambria" pitchFamily="34" charset="-120"/>
+              </a:rPr>
+              <a:t>218–1.454 € / Jahr</a:t>
+            </a:r>
+            <a:endParaRPr lang="en-US" sz="2400" dirty="0"/>
+          </a:p>
+        </p:txBody>
+      </p:sp>
+      <p:sp>
+        <p:nvSpPr>
           <p:cNvPr id="15" name="Text 11"/>
           <p:cNvSpPr txBox="1"/>
           <p:nvPr/>
         </p:nvSpPr>
         <p:spPr>
           <a:xfrm>
-            <a:off x="8823960" y="3840480"/>
-            <a:ext cx="2606040" cy="1097280"/>
+            <a:off x="8823960" y="4736592"/>
+            <a:ext cx="2606040" cy="822960"/>
           </a:xfrm>
           <a:prstGeom prst="rect">
             <a:avLst/>
@@ -15103,7 +15745,7 @@
                   <a:schemeClr val="accent5"/>
                 </a:solidFill>
               </a:rPr>
-              <a:t>TCO vom 19.10.2026 · Plattformpreise abgerufen am 27.10.2026 · Details in Kapitel 3</a:t>
+              <a:t>Basis: 40 Verordnungen pro Woche, ca. 2.080 im Jahr · Eingabezeit zu 20,97 €/h (Folie 9); Eingabezeiten sind Annahmen, im Pilot zu messen · Plattform: n8n Starter und Supabase Pro · ohne einmalige Einrichtung · TCO vom 19.10.2026, Plattformpreise abgerufen am 27.10.2026</a:t>
             </a:r>
             <a:endParaRPr lang="en-US" sz="1000" dirty="0"/>
           </a:p>
@@ -15154,6 +15796,50 @@
               <a:t>15</a:t>
             </a:fld>
             <a:endParaRPr lang="en-US"/>
+          </a:p>
+        </p:txBody>
+      </p:sp>
+      <p:sp>
+        <p:nvSpPr>
+          <p:cNvPr id="26" name="Text 12"/>
+          <p:cNvSpPr txBox="1"/>
+          <p:nvPr/>
+        </p:nvSpPr>
+        <p:spPr>
+          <a:xfrm>
+            <a:off x="548640" y="4709160"/>
+            <a:ext cx="7863840" cy="640080"/>
+          </a:xfrm>
+          <a:prstGeom prst="rect">
+            <a:avLst/>
+          </a:prstGeom>
+          <a:noFill/>
+          <a:ln/>
+        </p:spPr>
+        <p:txBody>
+          <a:bodyPr wrap="square" lIns="0" tIns="0" rIns="0" bIns="0" rtlCol="0" anchor="t"/>
+          <a:lstStyle/>
+          <a:p>
+            <a:pPr indent="0" marL="0">
+              <a:buNone/>
+            </a:pPr>
+            <a:r>
+              <a:rPr lang="en-US" sz="1300" i="0" dirty="0" b="1">
+                <a:solidFill>
+                  <a:srgbClr val="143D3B"/>
+                </a:solidFill>
+              </a:rPr>
+              <a:t>Warum das Formular und nicht der günstigste Kanal? </a:t>
+            </a:r>
+            <a:r>
+              <a:rPr lang="en-US" sz="1300" i="0" dirty="0" b="0">
+                <a:solidFill>
+                  <a:srgbClr val="143D3B"/>
+                </a:solidFill>
+              </a:rPr>
+              <a:t>Keine Lesefehler, und die Patientendaten werden ersetzt, bevor das Modell sie sieht. Qualität und Datenschutz gehen vor rund 700 € im Jahr. Foto und Scan sind der nächste Schritt.</a:t>
+            </a:r>
+            <a:endParaRPr lang="en-US" sz="1000" dirty="0"/>
           </a:p>
         </p:txBody>
       </p:sp>
@@ -16682,6 +17368,21 @@
               </a:rPr>
               <a:t>PII-Reduktion</a:t>
             </a:r>
+            <a:br>
+              <a:rPr lang="de-DE" sz="1500" dirty="0" b="1">
+                <a:solidFill>
+                  <a:schemeClr val="tx2"/>
+                </a:solidFill>
+              </a:rPr>
+            </a:br>
+            <a:r>
+              <a:rPr lang="de-DE" sz="1100" dirty="0" b="1">
+                <a:solidFill>
+                  <a:schemeClr val="tx2"/>
+                </a:solidFill>
+              </a:rPr>
+              <a:t>(personenbezogene Daten)</a:t>
+            </a:r>
           </a:p>
           <a:p>
             <a:pPr indent="0" marL="0">
@@ -16693,7 +17394,7 @@
                   <a:schemeClr val="accent5"/>
                 </a:solidFill>
               </a:rPr>
-              <a:t>bevor ein Sprachmodell die Daten sieht</a:t>
+              <a:t>vor dem Sprachmodell</a:t>
             </a:r>
           </a:p>
         </p:txBody>

</xml_diff>

<commit_message>
Kapitel 3: Kosten je Eingabekanal, Begründung Formular; Kapitel 4: PII erklärt; Folie 15 Foto wie Kapitel 3
Co-Authored-By: Claude Opus 5.5 <noreply@anthropic.com>
Claude-Session: https://claude.ai/code/session_01Fiy9oHnQhARrzuwrUokJ12
</commit_message>
<xml_diff>
--- a/docs/praesentation/Verordnungcheck_Thomas_Valentin_Derk.pptx
+++ b/docs/praesentation/Verordnungcheck_Thomas_Valentin_Derk.pptx
@@ -1595,7 +1595,7 @@
           <a:p>
             <a:r>
               <a:rPr lang="en-US" dirty="0"/>
-              <a:t>Wir haben bewusst nicht den günstigsten Kanal gewählt, sondern das Formular: keine Lesefehler, und die Patientendaten werden ersetzt, bevor das Modell sie sieht. Qualität und Datenschutz gehen vor rund 700 € im Jahr. Foto und Scan sind der nächste Schritt; eine Scan-Variante läuft als Prototyp, ist aber noch nicht getestet.</a:t>
+              <a:t>Wir haben bewusst nicht den günstigsten Kanal gewählt, sondern das Formular: keine Lesefehler, und die Patientendaten werden ersetzt, bevor das Modell sie sieht. Qualität und Datenschutz gehen vor rund 700 € im Jahr. Foto und Scan sind der nächste Schritt; eine Foto- und Scan-Variante läuft als Prototyp, liest aber Ankreuzfelder noch oft falsch und war nicht in der Testbatterie.</a:t>
             </a:r>
             <a:endParaRPr lang="en-US" dirty="0"/>
           </a:p>
@@ -14565,7 +14565,7 @@
                           <a:ea typeface="Calibri" pitchFamily="34" charset="-122"/>
                           <a:cs typeface="Calibri" pitchFamily="34" charset="-120"/>
                         </a:rPr>
-                        <a:t>Prototyp, noch nicht getestet</a:t>
+                        <a:t>Prototyp</a:t>
                       </a:r>
                       <a:endParaRPr lang="en-US" sz="1300" dirty="0">
                         <a:latin typeface="Calibri" charset="0"/>
@@ -14633,7 +14633,7 @@
                           <a:ea typeface="Calibri" pitchFamily="34" charset="-122"/>
                           <a:cs typeface="Calibri" pitchFamily="34" charset="-120"/>
                         </a:rPr>
-                        <a:t>Schnellste Eingabe, aber Lesefehler möglich</a:t>
+                        <a:t>Schnellste Eingabe, aber im Test Ankreuzfelder oft falsch gelesen</a:t>
                       </a:r>
                       <a:endParaRPr lang="en-US" sz="1300" dirty="0">
                         <a:latin typeface="Calibri" charset="0"/>

</xml_diff>